<commit_message>
Revise pitch slide 10 issuer beat, demo camera, and drop fake live shot
MPA keeps one protocol and swaps the issuer. The YouTube script opens on two grant cards, not chat. Slide 9 uses four callouts instead of the start-screen screenshot.

Co-authored-by: do0x0ob <do0x0ob@protonmail.com>
</commit_message>
<xml_diff>
--- a/pitch/GrantOnce.pptx
+++ b/pitch/GrantOnce.pptx
@@ -3520,32 +3520,32 @@
         </p:nvSpPr>
         <p:spPr>
           <a:xfrm>
-            <a:off x="731520" y="1645920"/>
-            <a:ext cx="10515600" cy="914400"/>
-          </a:xfrm>
-          <a:prstGeom prst="rect">
-            <a:avLst/>
-          </a:prstGeom>
-          <a:noFill/>
-        </p:spPr>
-        <p:txBody>
-          <a:bodyPr wrap="square" anchor="t"/>
-          <a:lstStyle/>
-          <a:p>
-            <a:pPr algn="l">
-              <a:spcAft>
-                <a:spcPts val="600"/>
-              </a:spcAft>
-            </a:pPr>
-            <a:r>
-              <a:rPr sz="3200" b="1">
+            <a:off x="731520" y="1051560"/>
+            <a:ext cx="10515600" cy="640080"/>
+          </a:xfrm>
+          <a:prstGeom prst="rect">
+            <a:avLst/>
+          </a:prstGeom>
+          <a:noFill/>
+        </p:spPr>
+        <p:txBody>
+          <a:bodyPr wrap="square" anchor="t"/>
+          <a:lstStyle/>
+          <a:p>
+            <a:pPr algn="l">
+              <a:spcAft>
+                <a:spcPts val="600"/>
+              </a:spcAft>
+            </a:pPr>
+            <a:r>
+              <a:rPr sz="2400" b="1">
                 <a:solidFill>
                   <a:srgbClr val="1C1612"/>
                 </a:solidFill>
                 <a:latin typeface="Microsoft JhengHei"/>
                 <a:rFonts ascii="Microsoft JhengHei" hAnsi="Microsoft JhengHei" eastAsia="Microsoft JhengHei" cs="Microsoft JhengHei"/>
               </a:rPr>
-              <a:t>多個委託人，約束同一個代理人。</a:t>
+              <a:t>多個委託人，約束同一個代理人。一人一匣。</a:t>
             </a:r>
           </a:p>
         </p:txBody>
@@ -3558,32 +3558,32 @@
         </p:nvSpPr>
         <p:spPr>
           <a:xfrm>
-            <a:off x="731520" y="2926080"/>
-            <a:ext cx="10515600" cy="640080"/>
-          </a:xfrm>
-          <a:prstGeom prst="rect">
-            <a:avLst/>
-          </a:prstGeom>
-          <a:noFill/>
-        </p:spPr>
-        <p:txBody>
-          <a:bodyPr wrap="square" anchor="t"/>
-          <a:lstStyle/>
-          <a:p>
-            <a:pPr algn="l">
-              <a:spcAft>
-                <a:spcPts val="600"/>
-              </a:spcAft>
-            </a:pPr>
-            <a:r>
-              <a:rPr sz="3200" b="1">
+            <a:off x="731520" y="1965960"/>
+            <a:ext cx="10515600" cy="457200"/>
+          </a:xfrm>
+          <a:prstGeom prst="rect">
+            <a:avLst/>
+          </a:prstGeom>
+          <a:noFill/>
+        </p:spPr>
+        <p:txBody>
+          <a:bodyPr wrap="square" anchor="t"/>
+          <a:lstStyle/>
+          <a:p>
+            <a:pPr algn="l">
+              <a:spcAft>
+                <a:spcPts val="600"/>
+              </a:spcAft>
+            </a:pPr>
+            <a:r>
+              <a:rPr sz="2800" b="1">
                 <a:solidFill>
                   <a:srgbClr val="1F4A3D"/>
                 </a:solidFill>
                 <a:latin typeface="Microsoft JhengHei"/>
                 <a:rFonts ascii="Microsoft JhengHei" hAnsi="Microsoft JhengHei" eastAsia="Microsoft JhengHei" cs="Microsoft JhengHei"/>
               </a:rPr>
-              <a:t>一人一匣。</a:t>
+              <a:t>同一套 Grant。換簽發人。</a:t>
             </a:r>
           </a:p>
         </p:txBody>
@@ -3596,39 +3596,115 @@
         </p:nvSpPr>
         <p:spPr>
           <a:xfrm>
-            <a:off x="731520" y="3931920"/>
-            <a:ext cx="10515600" cy="640080"/>
-          </a:xfrm>
-          <a:prstGeom prst="rect">
-            <a:avLst/>
-          </a:prstGeom>
-          <a:noFill/>
-        </p:spPr>
-        <p:txBody>
-          <a:bodyPr wrap="square" anchor="t"/>
-          <a:lstStyle/>
-          <a:p>
-            <a:pPr algn="l">
-              <a:spcAft>
-                <a:spcPts val="600"/>
-              </a:spcAft>
-            </a:pPr>
-            <a:r>
-              <a:rPr sz="2200" b="0">
+            <a:off x="731520" y="2743200"/>
+            <a:ext cx="10515600" cy="502920"/>
+          </a:xfrm>
+          <a:prstGeom prst="rect">
+            <a:avLst/>
+          </a:prstGeom>
+          <a:noFill/>
+        </p:spPr>
+        <p:txBody>
+          <a:bodyPr wrap="square" anchor="t"/>
+          <a:lstStyle/>
+          <a:p>
+            <a:pPr algn="l">
+              <a:spcAft>
+                <a:spcPts val="600"/>
+              </a:spcAft>
+            </a:pPr>
+            <a:r>
+              <a:rPr sz="2000" b="0">
+                <a:solidFill>
+                  <a:srgbClr val="1C1612"/>
+                </a:solidFill>
+                <a:latin typeface="Microsoft JhengHei"/>
+                <a:rFonts ascii="Microsoft JhengHei" hAnsi="Microsoft JhengHei" eastAsia="Microsoft JhengHei" cs="Microsoft JhengHei"/>
+              </a:rPr>
+              <a:t>主家搬家：簽發人 = 本人（同意）</a:t>
+            </a:r>
+          </a:p>
+        </p:txBody>
+      </p:sp>
+      <p:sp>
+        <p:nvSpPr>
+          <p:cNvPr id="7" name="TextBox 6"/>
+          <p:cNvSpPr txBox="1"/>
+          <p:nvPr/>
+        </p:nvSpPr>
+        <p:spPr>
+          <a:xfrm>
+            <a:off x="731520" y="3246120"/>
+            <a:ext cx="10515600" cy="502920"/>
+          </a:xfrm>
+          <a:prstGeom prst="rect">
+            <a:avLst/>
+          </a:prstGeom>
+          <a:noFill/>
+        </p:spPr>
+        <p:txBody>
+          <a:bodyPr wrap="square" anchor="t"/>
+          <a:lstStyle/>
+          <a:p>
+            <a:pPr algn="l">
+              <a:spcAft>
+                <a:spcPts val="600"/>
+              </a:spcAft>
+            </a:pPr>
+            <a:r>
+              <a:rPr sz="2000" b="0">
+                <a:solidFill>
+                  <a:srgbClr val="1C1612"/>
+                </a:solidFill>
+                <a:latin typeface="Microsoft JhengHei"/>
+                <a:rFonts ascii="Microsoft JhengHei" hAnsi="Microsoft JhengHei" eastAsia="Microsoft JhengHei" cs="Microsoft JhengHei"/>
+              </a:rPr>
+              <a:t>執法調閱：簽發人 = 法院／搜索票，不是機關甲</a:t>
+            </a:r>
+          </a:p>
+        </p:txBody>
+      </p:sp>
+      <p:sp>
+        <p:nvSpPr>
+          <p:cNvPr id="8" name="TextBox 7"/>
+          <p:cNvSpPr txBox="1"/>
+          <p:nvPr/>
+        </p:nvSpPr>
+        <p:spPr>
+          <a:xfrm>
+            <a:off x="731520" y="4114800"/>
+            <a:ext cx="10515600" cy="822960"/>
+          </a:xfrm>
+          <a:prstGeom prst="rect">
+            <a:avLst/>
+          </a:prstGeom>
+          <a:noFill/>
+        </p:spPr>
+        <p:txBody>
+          <a:bodyPr wrap="square" anchor="t"/>
+          <a:lstStyle/>
+          <a:p>
+            <a:pPr algn="l">
+              <a:spcAft>
+                <a:spcPts val="600"/>
+              </a:spcAft>
+            </a:pPr>
+            <a:r>
+              <a:rPr sz="1800" b="0">
                 <a:solidFill>
                   <a:srgbClr val="6B6258"/>
                 </a:solidFill>
                 <a:latin typeface="Microsoft JhengHei"/>
                 <a:rFonts ascii="Microsoft JhengHei" hAnsi="Microsoft JhengHei" eastAsia="Microsoft JhengHei" cs="Microsoft JhengHei"/>
               </a:rPr>
-              <a:t>不是一人一把萬能鑰匙。</a:t>
-            </a:r>
-          </a:p>
-        </p:txBody>
-      </p:sp>
-      <p:sp>
-        <p:nvSpPr>
-          <p:cNvPr id="7" name="TextBox 6"/>
+              <a:t>甲是收件人。乙仍簽署這包是他的。人還在場。</a:t>
+            </a:r>
+          </a:p>
+        </p:txBody>
+      </p:sp>
+      <p:sp>
+        <p:nvSpPr>
+          <p:cNvPr id="9" name="TextBox 8"/>
           <p:cNvSpPr txBox="1"/>
           <p:nvPr/>
         </p:nvSpPr>
@@ -3666,7 +3742,7 @@
       </p:sp>
       <p:sp>
         <p:nvSpPr>
-          <p:cNvPr id="8" name="TextBox 7"/>
+          <p:cNvPr id="10" name="TextBox 9"/>
           <p:cNvSpPr txBox="1"/>
           <p:nvPr/>
         </p:nvSpPr>
@@ -6983,7 +7059,7 @@
         </p:nvSpPr>
         <p:spPr>
           <a:xfrm>
-            <a:off x="548640" y="640080"/>
+            <a:off x="548640" y="777240"/>
             <a:ext cx="11064240" cy="365760"/>
           </a:xfrm>
           <a:prstGeom prst="rect">
@@ -7008,38 +7084,482 @@
                 <a:latin typeface="Microsoft JhengHei"/>
                 <a:rFonts ascii="Microsoft JhengHei" hAnsi="Microsoft JhengHei" eastAsia="Microsoft JhengHei" cs="Microsoft JhengHei"/>
               </a:rPr>
-              <a:t>委託人　｜　代理人　｜　機關＋稽核</a:t>
-            </a:r>
-          </a:p>
-        </p:txBody>
-      </p:sp>
-      <p:pic>
-        <p:nvPicPr>
-          <p:cNvPr id="5" name="Picture 4" descr="02-two-grants.png"/>
-          <p:cNvPicPr>
-            <a:picLocks noChangeAspect="1"/>
-          </p:cNvPicPr>
-          <p:nvPr/>
-        </p:nvPicPr>
-        <p:blipFill>
-          <a:blip r:embed="rId2"/>
-          <a:stretch>
-            <a:fillRect/>
-          </a:stretch>
-        </p:blipFill>
-        <p:spPr>
-          <a:xfrm>
-            <a:off x="1554480" y="1097280"/>
-            <a:ext cx="8119872" cy="5074920"/>
-          </a:xfrm>
-          <a:prstGeom prst="rect">
-            <a:avLst/>
-          </a:prstGeom>
-        </p:spPr>
-      </p:pic>
+              <a:t>三欄同一畫面。看這四件事。</a:t>
+            </a:r>
+          </a:p>
+        </p:txBody>
+      </p:sp>
+      <p:sp>
+        <p:nvSpPr>
+          <p:cNvPr id="5" name="Rounded Rectangle 4"/>
+          <p:cNvSpPr/>
+          <p:nvPr/>
+        </p:nvSpPr>
+        <p:spPr>
+          <a:xfrm>
+            <a:off x="548640" y="1371600"/>
+            <a:ext cx="2651760" cy="4023360"/>
+          </a:xfrm>
+          <a:prstGeom prst="roundRect">
+            <a:avLst/>
+          </a:prstGeom>
+          <a:solidFill>
+            <a:srgbClr val="FBF7EE"/>
+          </a:solidFill>
+          <a:ln>
+            <a:solidFill>
+              <a:srgbClr val="D9D0C0"/>
+            </a:solidFill>
+          </a:ln>
+        </p:spPr>
+        <p:style>
+          <a:lnRef idx="1">
+            <a:schemeClr val="accent1"/>
+          </a:lnRef>
+          <a:fillRef idx="3">
+            <a:schemeClr val="accent1"/>
+          </a:fillRef>
+          <a:effectRef idx="2">
+            <a:schemeClr val="accent1"/>
+          </a:effectRef>
+          <a:fontRef idx="minor">
+            <a:schemeClr val="lt1"/>
+          </a:fontRef>
+        </p:style>
+        <p:txBody>
+          <a:bodyPr rtlCol="0" anchor="ctr"/>
+          <a:lstStyle/>
+          <a:p>
+            <a:pPr algn="ctr"/>
+          </a:p>
+        </p:txBody>
+      </p:sp>
       <p:sp>
         <p:nvSpPr>
           <p:cNvPr id="6" name="TextBox 5"/>
+          <p:cNvSpPr txBox="1"/>
+          <p:nvPr/>
+        </p:nvSpPr>
+        <p:spPr>
+          <a:xfrm>
+            <a:off x="713232" y="1554480"/>
+            <a:ext cx="2331720" cy="3657600"/>
+          </a:xfrm>
+          <a:prstGeom prst="rect">
+            <a:avLst/>
+          </a:prstGeom>
+          <a:noFill/>
+        </p:spPr>
+        <p:txBody>
+          <a:bodyPr wrap="square" anchor="t"/>
+          <a:lstStyle/>
+          <a:p>
+            <a:pPr algn="l">
+              <a:spcAft>
+                <a:spcPts val="600"/>
+              </a:spcAft>
+            </a:pPr>
+            <a:r>
+              <a:rPr sz="1400" b="1">
+                <a:solidFill>
+                  <a:srgbClr val="6B6258"/>
+                </a:solidFill>
+                <a:latin typeface="Microsoft JhengHei"/>
+                <a:rFonts ascii="Microsoft JhengHei" hAnsi="Microsoft JhengHei" eastAsia="Microsoft JhengHei" cs="Microsoft JhengHei"/>
+              </a:rPr>
+              <a:t>甲匣</a:t>
+            </a:r>
+          </a:p>
+          <a:p>
+            <a:pPr algn="l">
+              <a:spcAft>
+                <a:spcPts val="600"/>
+              </a:spcAft>
+            </a:pPr>
+            <a:r>
+              <a:rPr sz="2200" b="1">
+                <a:solidFill>
+                  <a:srgbClr val="1C1612"/>
+                </a:solidFill>
+                <a:latin typeface="Microsoft JhengHei"/>
+                <a:rFonts ascii="Microsoft JhengHei" hAnsi="Microsoft JhengHei" eastAsia="Microsoft JhengHei" cs="Microsoft JhengHei"/>
+              </a:rPr>
+              <a:t>戶籍＋親子</a:t>
+            </a:r>
+          </a:p>
+          <a:p>
+            <a:pPr algn="l">
+              <a:spcAft>
+                <a:spcPts val="600"/>
+              </a:spcAft>
+            </a:pPr>
+            <a:r>
+              <a:rPr sz="1400" b="0">
+                <a:solidFill>
+                  <a:srgbClr val="6B6258"/>
+                </a:solidFill>
+                <a:latin typeface="Microsoft JhengHei"/>
+                <a:rFonts ascii="Microsoft JhengHei" hAnsi="Microsoft JhengHei" eastAsia="Microsoft JhengHei" cs="Microsoft JhengHei"/>
+              </a:rPr>
+              <a:t>沒有電號、所得</a:t>
+            </a:r>
+          </a:p>
+        </p:txBody>
+      </p:sp>
+      <p:sp>
+        <p:nvSpPr>
+          <p:cNvPr id="7" name="Rounded Rectangle 6"/>
+          <p:cNvSpPr/>
+          <p:nvPr/>
+        </p:nvSpPr>
+        <p:spPr>
+          <a:xfrm>
+            <a:off x="3429000" y="1371600"/>
+            <a:ext cx="2651760" cy="4023360"/>
+          </a:xfrm>
+          <a:prstGeom prst="roundRect">
+            <a:avLst/>
+          </a:prstGeom>
+          <a:solidFill>
+            <a:srgbClr val="FBF7EE"/>
+          </a:solidFill>
+          <a:ln>
+            <a:solidFill>
+              <a:srgbClr val="D9D0C0"/>
+            </a:solidFill>
+          </a:ln>
+        </p:spPr>
+        <p:style>
+          <a:lnRef idx="1">
+            <a:schemeClr val="accent1"/>
+          </a:lnRef>
+          <a:fillRef idx="3">
+            <a:schemeClr val="accent1"/>
+          </a:fillRef>
+          <a:effectRef idx="2">
+            <a:schemeClr val="accent1"/>
+          </a:effectRef>
+          <a:fontRef idx="minor">
+            <a:schemeClr val="lt1"/>
+          </a:fontRef>
+        </p:style>
+        <p:txBody>
+          <a:bodyPr rtlCol="0" anchor="ctr"/>
+          <a:lstStyle/>
+          <a:p>
+            <a:pPr algn="ctr"/>
+          </a:p>
+        </p:txBody>
+      </p:sp>
+      <p:sp>
+        <p:nvSpPr>
+          <p:cNvPr id="8" name="TextBox 7"/>
+          <p:cNvSpPr txBox="1"/>
+          <p:nvPr/>
+        </p:nvSpPr>
+        <p:spPr>
+          <a:xfrm>
+            <a:off x="3593592" y="1554480"/>
+            <a:ext cx="2331720" cy="3657600"/>
+          </a:xfrm>
+          <a:prstGeom prst="rect">
+            <a:avLst/>
+          </a:prstGeom>
+          <a:noFill/>
+        </p:spPr>
+        <p:txBody>
+          <a:bodyPr wrap="square" anchor="t"/>
+          <a:lstStyle/>
+          <a:p>
+            <a:pPr algn="l">
+              <a:spcAft>
+                <a:spcPts val="600"/>
+              </a:spcAft>
+            </a:pPr>
+            <a:r>
+              <a:rPr sz="1400" b="1">
+                <a:solidFill>
+                  <a:srgbClr val="6B6258"/>
+                </a:solidFill>
+                <a:latin typeface="Microsoft JhengHei"/>
+                <a:rFonts ascii="Microsoft JhengHei" hAnsi="Microsoft JhengHei" eastAsia="Microsoft JhengHei" cs="Microsoft JhengHei"/>
+              </a:rPr>
+              <a:t>乙匣</a:t>
+            </a:r>
+          </a:p>
+          <a:p>
+            <a:pPr algn="l">
+              <a:spcAft>
+                <a:spcPts val="600"/>
+              </a:spcAft>
+            </a:pPr>
+            <a:r>
+              <a:rPr sz="2200" b="1">
+                <a:solidFill>
+                  <a:srgbClr val="1C1612"/>
+                </a:solidFill>
+                <a:latin typeface="Microsoft JhengHei"/>
+                <a:rFonts ascii="Microsoft JhengHei" hAnsi="Microsoft JhengHei" eastAsia="Microsoft JhengHei" cs="Microsoft JhengHei"/>
+              </a:rPr>
+              <a:t>電號＋三月用電</a:t>
+            </a:r>
+          </a:p>
+          <a:p>
+            <a:pPr algn="l">
+              <a:spcAft>
+                <a:spcPts val="600"/>
+              </a:spcAft>
+            </a:pPr>
+            <a:r>
+              <a:rPr sz="1400" b="0">
+                <a:solidFill>
+                  <a:srgbClr val="6B6258"/>
+                </a:solidFill>
+                <a:latin typeface="Microsoft JhengHei"/>
+                <a:rFonts ascii="Microsoft JhengHei" hAnsi="Microsoft JhengHei" eastAsia="Microsoft JhengHei" cs="Microsoft JhengHei"/>
+              </a:rPr>
+              <a:t>沒有戶籍、所得</a:t>
+            </a:r>
+          </a:p>
+        </p:txBody>
+      </p:sp>
+      <p:sp>
+        <p:nvSpPr>
+          <p:cNvPr id="9" name="Rounded Rectangle 8"/>
+          <p:cNvSpPr/>
+          <p:nvPr/>
+        </p:nvSpPr>
+        <p:spPr>
+          <a:xfrm>
+            <a:off x="6309360" y="1371600"/>
+            <a:ext cx="2651760" cy="4023360"/>
+          </a:xfrm>
+          <a:prstGeom prst="roundRect">
+            <a:avLst/>
+          </a:prstGeom>
+          <a:solidFill>
+            <a:srgbClr val="FBF7EE"/>
+          </a:solidFill>
+          <a:ln>
+            <a:solidFill>
+              <a:srgbClr val="D9D0C0"/>
+            </a:solidFill>
+          </a:ln>
+        </p:spPr>
+        <p:style>
+          <a:lnRef idx="1">
+            <a:schemeClr val="accent1"/>
+          </a:lnRef>
+          <a:fillRef idx="3">
+            <a:schemeClr val="accent1"/>
+          </a:fillRef>
+          <a:effectRef idx="2">
+            <a:schemeClr val="accent1"/>
+          </a:effectRef>
+          <a:fontRef idx="minor">
+            <a:schemeClr val="lt1"/>
+          </a:fontRef>
+        </p:style>
+        <p:txBody>
+          <a:bodyPr rtlCol="0" anchor="ctr"/>
+          <a:lstStyle/>
+          <a:p>
+            <a:pPr algn="ctr"/>
+          </a:p>
+        </p:txBody>
+      </p:sp>
+      <p:sp>
+        <p:nvSpPr>
+          <p:cNvPr id="10" name="TextBox 9"/>
+          <p:cNvSpPr txBox="1"/>
+          <p:nvPr/>
+        </p:nvSpPr>
+        <p:spPr>
+          <a:xfrm>
+            <a:off x="6473952" y="1554480"/>
+            <a:ext cx="2331720" cy="3657600"/>
+          </a:xfrm>
+          <a:prstGeom prst="rect">
+            <a:avLst/>
+          </a:prstGeom>
+          <a:noFill/>
+        </p:spPr>
+        <p:txBody>
+          <a:bodyPr wrap="square" anchor="t"/>
+          <a:lstStyle/>
+          <a:p>
+            <a:pPr algn="l">
+              <a:spcAft>
+                <a:spcPts val="600"/>
+              </a:spcAft>
+            </a:pPr>
+            <a:r>
+              <a:rPr sz="1400" b="1">
+                <a:solidFill>
+                  <a:srgbClr val="6B6258"/>
+                </a:solidFill>
+                <a:latin typeface="Microsoft JhengHei"/>
+                <a:rFonts ascii="Microsoft JhengHei" hAnsi="Microsoft JhengHei" eastAsia="Microsoft JhengHei" cs="Microsoft JhengHei"/>
+              </a:rPr>
+              <a:t>越權</a:t>
+            </a:r>
+          </a:p>
+          <a:p>
+            <a:pPr algn="l">
+              <a:spcAft>
+                <a:spcPts val="600"/>
+              </a:spcAft>
+            </a:pPr>
+            <a:r>
+              <a:rPr sz="2200" b="1">
+                <a:solidFill>
+                  <a:srgbClr val="1C1612"/>
+                </a:solidFill>
+                <a:latin typeface="Microsoft JhengHei"/>
+                <a:rFonts ascii="Microsoft JhengHei" hAnsi="Microsoft JhengHei" eastAsia="Microsoft JhengHei" cs="Microsoft JhengHei"/>
+              </a:rPr>
+              <a:t>乙要戶籍</a:t>
+            </a:r>
+          </a:p>
+          <a:p>
+            <a:pPr algn="l">
+              <a:spcAft>
+                <a:spcPts val="600"/>
+              </a:spcAft>
+            </a:pPr>
+            <a:r>
+              <a:rPr sz="1400" b="0">
+                <a:solidFill>
+                  <a:srgbClr val="9F1D1D"/>
+                </a:solidFill>
+                <a:latin typeface="Microsoft JhengHei"/>
+                <a:rFonts ascii="Microsoft JhengHei" hAnsi="Microsoft JhengHei" eastAsia="Microsoft JhengHei" cs="Microsoft JhengHei"/>
+              </a:rPr>
+              <a:t>403　半包也不給</a:t>
+            </a:r>
+          </a:p>
+        </p:txBody>
+      </p:sp>
+      <p:sp>
+        <p:nvSpPr>
+          <p:cNvPr id="11" name="Rounded Rectangle 10"/>
+          <p:cNvSpPr/>
+          <p:nvPr/>
+        </p:nvSpPr>
+        <p:spPr>
+          <a:xfrm>
+            <a:off x="9189720" y="1371600"/>
+            <a:ext cx="2651760" cy="4023360"/>
+          </a:xfrm>
+          <a:prstGeom prst="roundRect">
+            <a:avLst/>
+          </a:prstGeom>
+          <a:solidFill>
+            <a:srgbClr val="FBF7EE"/>
+          </a:solidFill>
+          <a:ln>
+            <a:solidFill>
+              <a:srgbClr val="D9D0C0"/>
+            </a:solidFill>
+          </a:ln>
+        </p:spPr>
+        <p:style>
+          <a:lnRef idx="1">
+            <a:schemeClr val="accent1"/>
+          </a:lnRef>
+          <a:fillRef idx="3">
+            <a:schemeClr val="accent1"/>
+          </a:fillRef>
+          <a:effectRef idx="2">
+            <a:schemeClr val="accent1"/>
+          </a:effectRef>
+          <a:fontRef idx="minor">
+            <a:schemeClr val="lt1"/>
+          </a:fontRef>
+        </p:style>
+        <p:txBody>
+          <a:bodyPr rtlCol="0" anchor="ctr"/>
+          <a:lstStyle/>
+          <a:p>
+            <a:pPr algn="ctr"/>
+          </a:p>
+        </p:txBody>
+      </p:sp>
+      <p:sp>
+        <p:nvSpPr>
+          <p:cNvPr id="12" name="TextBox 11"/>
+          <p:cNvSpPr txBox="1"/>
+          <p:nvPr/>
+        </p:nvSpPr>
+        <p:spPr>
+          <a:xfrm>
+            <a:off x="9354312" y="1554480"/>
+            <a:ext cx="2331720" cy="3657600"/>
+          </a:xfrm>
+          <a:prstGeom prst="rect">
+            <a:avLst/>
+          </a:prstGeom>
+          <a:noFill/>
+        </p:spPr>
+        <p:txBody>
+          <a:bodyPr wrap="square" anchor="t"/>
+          <a:lstStyle/>
+          <a:p>
+            <a:pPr algn="l">
+              <a:spcAft>
+                <a:spcPts val="600"/>
+              </a:spcAft>
+            </a:pPr>
+            <a:r>
+              <a:rPr sz="1400" b="1">
+                <a:solidFill>
+                  <a:srgbClr val="6B6258"/>
+                </a:solidFill>
+                <a:latin typeface="Microsoft JhengHei"/>
+                <a:rFonts ascii="Microsoft JhengHei" hAnsi="Microsoft JhengHei" eastAsia="Microsoft JhengHei" cs="Microsoft JhengHei"/>
+              </a:rPr>
+              <a:t>稽核</a:t>
+            </a:r>
+          </a:p>
+          <a:p>
+            <a:pPr algn="l">
+              <a:spcAft>
+                <a:spcPts val="600"/>
+              </a:spcAft>
+            </a:pPr>
+            <a:r>
+              <a:rPr sz="2200" b="1">
+                <a:solidFill>
+                  <a:srgbClr val="1C1612"/>
+                </a:solidFill>
+                <a:latin typeface="Microsoft JhengHei"/>
+                <a:rFonts ascii="Microsoft JhengHei" hAnsi="Microsoft JhengHei" eastAsia="Microsoft JhengHei" cs="Microsoft JhengHei"/>
+              </a:rPr>
+              <a:t>核准／擷取／送件</a:t>
+            </a:r>
+          </a:p>
+          <a:p>
+            <a:pPr algn="l">
+              <a:spcAft>
+                <a:spcPts val="600"/>
+              </a:spcAft>
+            </a:pPr>
+            <a:r>
+              <a:rPr sz="1400" b="0">
+                <a:solidFill>
+                  <a:srgbClr val="6B6258"/>
+                </a:solidFill>
+                <a:latin typeface="Microsoft JhengHei"/>
+                <a:rFonts ascii="Microsoft JhengHei" hAnsi="Microsoft JhengHei" eastAsia="Microsoft JhengHei" cs="Microsoft JhengHei"/>
+              </a:rPr>
+              <a:t>撤銷／拒絕</a:t>
+            </a:r>
+          </a:p>
+        </p:txBody>
+      </p:sp>
+      <p:sp>
+        <p:nvSpPr>
+          <p:cNvPr id="13" name="TextBox 12"/>
           <p:cNvSpPr txBox="1"/>
           <p:nvPr/>
         </p:nvSpPr>
@@ -7077,7 +7597,7 @@
       </p:sp>
       <p:sp>
         <p:nvSpPr>
-          <p:cNvPr id="7" name="TextBox 6"/>
+          <p:cNvPr id="14" name="TextBox 13"/>
           <p:cNvSpPr txBox="1"/>
           <p:nvPr/>
         </p:nvSpPr>

</xml_diff>

<commit_message>
Issue HMAC tickets after approve; drop actor self-assertion
Fetch and submit accept only an HMAC ticket (opaque grn_ jti or
Bearer Grant token). Runtime verifies iss/aud/fields/exp. MCP tools
no longer take actor. Keep consume-on-submit receipts and fat-token
contrast. Passkey/presenter self-assertion is out of this PR.

Co-authored-by: Harper Hsieh <do0x0ob@protonmail.com>
</commit_message>
<xml_diff>
--- a/pitch/GrantOnce.pptx
+++ b/pitch/GrantOnce.pptx
@@ -4275,6 +4275,44 @@
                 <a:latin typeface="Microsoft JhengHei"/>
                 <a:rFonts ascii="Microsoft JhengHei" hAnsi="Microsoft JhengHei" eastAsia="Microsoft JhengHei" cs="Microsoft JhengHei"/>
               </a:rPr>
+              <a:t>OID4VP／登入是下一層。</a:t>
+            </a:r>
+          </a:p>
+        </p:txBody>
+      </p:sp>
+      <p:sp>
+        <p:nvSpPr>
+          <p:cNvPr id="6" name="TextBox 5"/>
+          <p:cNvSpPr txBox="1"/>
+          <p:nvPr/>
+        </p:nvSpPr>
+        <p:spPr>
+          <a:xfrm>
+            <a:off x="731520" y="3291840"/>
+            <a:ext cx="10515600" cy="457200"/>
+          </a:xfrm>
+          <a:prstGeom prst="rect">
+            <a:avLst/>
+          </a:prstGeom>
+          <a:noFill/>
+        </p:spPr>
+        <p:txBody>
+          <a:bodyPr wrap="square" anchor="t"/>
+          <a:lstStyle/>
+          <a:p>
+            <a:pPr algn="l">
+              <a:spcAft>
+                <a:spcPts val="600"/>
+              </a:spcAft>
+            </a:pPr>
+            <a:r>
+              <a:rPr sz="2000" b="0">
+                <a:solidFill>
+                  <a:srgbClr val="6B6258"/>
+                </a:solidFill>
+                <a:latin typeface="Microsoft JhengHei"/>
+                <a:rFonts ascii="Microsoft JhengHei" hAnsi="Microsoft JhengHei" eastAsia="Microsoft JhengHei" cs="Microsoft JhengHei"/>
+              </a:rPr>
               <a:t>週末用合成資料。</a:t>
             </a:r>
           </a:p>
@@ -4282,7 +4320,7 @@
       </p:sp>
       <p:sp>
         <p:nvSpPr>
-          <p:cNvPr id="6" name="Rectangle 5"/>
+          <p:cNvPr id="7" name="Rectangle 6"/>
           <p:cNvSpPr/>
           <p:nvPr/>
         </p:nvSpPr>
@@ -4325,7 +4363,7 @@
       </p:sp>
       <p:sp>
         <p:nvSpPr>
-          <p:cNvPr id="7" name="TextBox 6"/>
+          <p:cNvPr id="8" name="TextBox 7"/>
           <p:cNvSpPr txBox="1"/>
           <p:nvPr/>
         </p:nvSpPr>
@@ -4363,7 +4401,7 @@
       </p:sp>
       <p:sp>
         <p:nvSpPr>
-          <p:cNvPr id="8" name="TextBox 7"/>
+          <p:cNvPr id="9" name="TextBox 8"/>
           <p:cNvSpPr txBox="1"/>
           <p:nvPr/>
         </p:nvSpPr>
@@ -4401,7 +4439,7 @@
       </p:sp>
       <p:sp>
         <p:nvSpPr>
-          <p:cNvPr id="9" name="TextBox 8"/>
+          <p:cNvPr id="10" name="TextBox 9"/>
           <p:cNvSpPr txBox="1"/>
           <p:nvPr/>
         </p:nvSpPr>
@@ -6027,7 +6065,7 @@
                 <a:latin typeface="Microsoft JhengHei"/>
                 <a:rFonts ascii="Microsoft JhengHei" hAnsi="Microsoft JhengHei" eastAsia="Microsoft JhengHei" cs="Microsoft JhengHei"/>
               </a:rPr>
-              <a:t>乙要戶籍。</a:t>
+              <a:t>乙要戶籍。用匣號當票。</a:t>
             </a:r>
           </a:p>
         </p:txBody>
@@ -6096,14 +6134,14 @@
               </a:spcAft>
             </a:pPr>
             <a:r>
-              <a:rPr sz="2400" b="0">
+              <a:rPr sz="2000" b="0">
                 <a:solidFill>
                   <a:srgbClr val="6B6258"/>
                 </a:solidFill>
                 <a:latin typeface="Microsoft JhengHei"/>
                 <a:rFonts ascii="Microsoft JhengHei" hAnsi="Microsoft JhengHei" eastAsia="Microsoft JhengHei" cs="Microsoft JhengHei"/>
               </a:rPr>
-              <a:t>不回傳半包欄位。</a:t>
+              <a:t>OVERSCOPED · BAD_TICKET。不回傳半包。</a:t>
             </a:r>
           </a:p>
         </p:txBody>
@@ -6309,14 +6347,14 @@
               </a:spcAft>
             </a:pPr>
             <a:r>
-              <a:rPr sz="3600" b="1">
+              <a:rPr sz="3200" b="1">
                 <a:solidFill>
                   <a:srgbClr val="1C1612"/>
                 </a:solidFill>
                 <a:latin typeface="Microsoft JhengHei"/>
                 <a:rFonts ascii="Microsoft JhengHei" hAnsi="Microsoft JhengHei" eastAsia="Microsoft JhengHei" cs="Microsoft JhengHei"/>
               </a:rPr>
-              <a:t>送件  →  匣耗用。</a:t>
+              <a:t>送件  →  匣耗用。明文改收據。</a:t>
             </a:r>
           </a:p>
         </p:txBody>
@@ -6605,7 +6643,7 @@
                 <a:latin typeface="Microsoft JhengHei"/>
                 <a:rFonts ascii="Microsoft JhengHei" hAnsi="Microsoft JhengHei" eastAsia="Microsoft JhengHei" cs="Microsoft JhengHei"/>
               </a:rPr>
-              <a:t>Grant 白名單</a:t>
+              <a:t>HMAC ticket</a:t>
             </a:r>
           </a:p>
         </p:txBody>
@@ -6643,7 +6681,7 @@
                 <a:latin typeface="Microsoft JhengHei"/>
                 <a:rFonts ascii="Microsoft JhengHei" hAnsi="Microsoft JhengHei" eastAsia="Microsoft JhengHei" cs="Microsoft JhengHei"/>
               </a:rPr>
-              <a:t>Bearer Grant G-jia / G-yi。沒有 fields:*。</a:t>
+              <a:t>runtime 驗 iss／aud／fields／exp。匣號不是憑證。</a:t>
             </a:r>
           </a:p>
         </p:txBody>
@@ -6719,7 +6757,7 @@
                 <a:latin typeface="Microsoft JhengHei"/>
                 <a:rFonts ascii="Microsoft JhengHei" hAnsi="Microsoft JhengHei" eastAsia="Microsoft JhengHei" cs="Microsoft JhengHei"/>
               </a:rPr>
-              <a:t>甲、乙各存各的。不能聯集。</a:t>
+              <a:t>甲、乙各存各的。拿錯匣 403。</a:t>
             </a:r>
           </a:p>
         </p:txBody>
@@ -6871,7 +6909,7 @@
                 <a:latin typeface="Microsoft JhengHei"/>
                 <a:rFonts ascii="Microsoft JhengHei" hAnsi="Microsoft JhengHei" eastAsia="Microsoft JhengHei" cs="Microsoft JhengHei"/>
               </a:rPr>
-              <a:t>模型頂多改措辭。不能發匣、不能放行欄位。</a:t>
+              <a:t>模型不能發匣、不能核准、不能放行欄位。</a:t>
             </a:r>
           </a:p>
         </p:txBody>

</xml_diff>

<commit_message>
Drop leftover HMAC files after rebasing onto main
Main landed #3 HMAC tickets after this branch forked. Rebase kept
grant.ts, protocol inspector, and ticket helpers that do not belong
in the two-key passkey + legal-duty protocol. Restore the original
#4 sources and delete the HMAC leftovers.

Co-authored-by: Harper Hsieh <do0x0ob@protonmail.com>
</commit_message>
<xml_diff>
--- a/pitch/GrantOnce.pptx
+++ b/pitch/GrantOnce.pptx
@@ -4275,44 +4275,6 @@
                 <a:latin typeface="Microsoft JhengHei"/>
                 <a:rFonts ascii="Microsoft JhengHei" hAnsi="Microsoft JhengHei" eastAsia="Microsoft JhengHei" cs="Microsoft JhengHei"/>
               </a:rPr>
-              <a:t>OID4VP／登入是下一層。</a:t>
-            </a:r>
-          </a:p>
-        </p:txBody>
-      </p:sp>
-      <p:sp>
-        <p:nvSpPr>
-          <p:cNvPr id="6" name="TextBox 5"/>
-          <p:cNvSpPr txBox="1"/>
-          <p:nvPr/>
-        </p:nvSpPr>
-        <p:spPr>
-          <a:xfrm>
-            <a:off x="731520" y="3291840"/>
-            <a:ext cx="10515600" cy="457200"/>
-          </a:xfrm>
-          <a:prstGeom prst="rect">
-            <a:avLst/>
-          </a:prstGeom>
-          <a:noFill/>
-        </p:spPr>
-        <p:txBody>
-          <a:bodyPr wrap="square" anchor="t"/>
-          <a:lstStyle/>
-          <a:p>
-            <a:pPr algn="l">
-              <a:spcAft>
-                <a:spcPts val="600"/>
-              </a:spcAft>
-            </a:pPr>
-            <a:r>
-              <a:rPr sz="2000" b="0">
-                <a:solidFill>
-                  <a:srgbClr val="6B6258"/>
-                </a:solidFill>
-                <a:latin typeface="Microsoft JhengHei"/>
-                <a:rFonts ascii="Microsoft JhengHei" hAnsi="Microsoft JhengHei" eastAsia="Microsoft JhengHei" cs="Microsoft JhengHei"/>
-              </a:rPr>
               <a:t>週末用合成資料。</a:t>
             </a:r>
           </a:p>
@@ -4320,7 +4282,7 @@
       </p:sp>
       <p:sp>
         <p:nvSpPr>
-          <p:cNvPr id="7" name="Rectangle 6"/>
+          <p:cNvPr id="6" name="Rectangle 5"/>
           <p:cNvSpPr/>
           <p:nvPr/>
         </p:nvSpPr>
@@ -4363,7 +4325,7 @@
       </p:sp>
       <p:sp>
         <p:nvSpPr>
-          <p:cNvPr id="8" name="TextBox 7"/>
+          <p:cNvPr id="7" name="TextBox 6"/>
           <p:cNvSpPr txBox="1"/>
           <p:nvPr/>
         </p:nvSpPr>
@@ -4401,7 +4363,7 @@
       </p:sp>
       <p:sp>
         <p:nvSpPr>
-          <p:cNvPr id="9" name="TextBox 8"/>
+          <p:cNvPr id="8" name="TextBox 7"/>
           <p:cNvSpPr txBox="1"/>
           <p:nvPr/>
         </p:nvSpPr>
@@ -4439,7 +4401,7 @@
       </p:sp>
       <p:sp>
         <p:nvSpPr>
-          <p:cNvPr id="10" name="TextBox 9"/>
+          <p:cNvPr id="9" name="TextBox 8"/>
           <p:cNvSpPr txBox="1"/>
           <p:nvPr/>
         </p:nvSpPr>
@@ -6065,7 +6027,7 @@
                 <a:latin typeface="Microsoft JhengHei"/>
                 <a:rFonts ascii="Microsoft JhengHei" hAnsi="Microsoft JhengHei" eastAsia="Microsoft JhengHei" cs="Microsoft JhengHei"/>
               </a:rPr>
-              <a:t>乙要戶籍。用匣號當票。</a:t>
+              <a:t>乙要戶籍。</a:t>
             </a:r>
           </a:p>
         </p:txBody>
@@ -6134,14 +6096,14 @@
               </a:spcAft>
             </a:pPr>
             <a:r>
-              <a:rPr sz="2000" b="0">
+              <a:rPr sz="2400" b="0">
                 <a:solidFill>
                   <a:srgbClr val="6B6258"/>
                 </a:solidFill>
                 <a:latin typeface="Microsoft JhengHei"/>
                 <a:rFonts ascii="Microsoft JhengHei" hAnsi="Microsoft JhengHei" eastAsia="Microsoft JhengHei" cs="Microsoft JhengHei"/>
               </a:rPr>
-              <a:t>OVERSCOPED · BAD_TICKET。不回傳半包。</a:t>
+              <a:t>不回傳半包欄位。</a:t>
             </a:r>
           </a:p>
         </p:txBody>
@@ -6347,14 +6309,14 @@
               </a:spcAft>
             </a:pPr>
             <a:r>
-              <a:rPr sz="3200" b="1">
+              <a:rPr sz="3600" b="1">
                 <a:solidFill>
                   <a:srgbClr val="1C1612"/>
                 </a:solidFill>
                 <a:latin typeface="Microsoft JhengHei"/>
                 <a:rFonts ascii="Microsoft JhengHei" hAnsi="Microsoft JhengHei" eastAsia="Microsoft JhengHei" cs="Microsoft JhengHei"/>
               </a:rPr>
-              <a:t>送件  →  匣耗用。明文改收據。</a:t>
+              <a:t>送件  →  匣耗用。</a:t>
             </a:r>
           </a:p>
         </p:txBody>
@@ -6643,7 +6605,7 @@
                 <a:latin typeface="Microsoft JhengHei"/>
                 <a:rFonts ascii="Microsoft JhengHei" hAnsi="Microsoft JhengHei" eastAsia="Microsoft JhengHei" cs="Microsoft JhengHei"/>
               </a:rPr>
-              <a:t>HMAC ticket</a:t>
+              <a:t>Grant 白名單</a:t>
             </a:r>
           </a:p>
         </p:txBody>
@@ -6681,7 +6643,7 @@
                 <a:latin typeface="Microsoft JhengHei"/>
                 <a:rFonts ascii="Microsoft JhengHei" hAnsi="Microsoft JhengHei" eastAsia="Microsoft JhengHei" cs="Microsoft JhengHei"/>
               </a:rPr>
-              <a:t>runtime 驗 iss／aud／fields／exp。匣號不是憑證。</a:t>
+              <a:t>Bearer Grant G-jia / G-yi。沒有 fields:*。</a:t>
             </a:r>
           </a:p>
         </p:txBody>
@@ -6757,7 +6719,7 @@
                 <a:latin typeface="Microsoft JhengHei"/>
                 <a:rFonts ascii="Microsoft JhengHei" hAnsi="Microsoft JhengHei" eastAsia="Microsoft JhengHei" cs="Microsoft JhengHei"/>
               </a:rPr>
-              <a:t>甲、乙各存各的。拿錯匣 403。</a:t>
+              <a:t>甲、乙各存各的。不能聯集。</a:t>
             </a:r>
           </a:p>
         </p:txBody>
@@ -6909,7 +6871,7 @@
                 <a:latin typeface="Microsoft JhengHei"/>
                 <a:rFonts ascii="Microsoft JhengHei" hAnsi="Microsoft JhengHei" eastAsia="Microsoft JhengHei" cs="Microsoft JhengHei"/>
               </a:rPr>
-              <a:t>模型不能發匣、不能核准、不能放行欄位。</a:t>
+              <a:t>模型頂多改措辭。不能發匣、不能放行欄位。</a:t>
             </a:r>
           </a:p>
         </p:txBody>

</xml_diff>